<commit_message>
milwaukee-ppt：Before/After 版式（layout 3）与使用说明；版式调研；issue tracker 约定
为 implement-spec #10 的 worktree 提供基线。

Co-Authored-By: Claude <noreply@anthropic.com>
</commit_message>
<xml_diff>
--- a/skills/milwaukee-ppt/assets/MS_Template.pptx
+++ b/skills/milwaukee-ppt/assets/MS_Template.pptx
@@ -11,6 +11,7 @@
     <p:sldId id="261" r:id="rId5"/>
     <p:sldId id="259" r:id="rId6"/>
     <p:sldId id="298" r:id="rId7"/>
+    <p:sldId id="299" r:id="rId15"/>
   </p:sldIdLst>
   <p:sldSz cx="12192000" cy="6858000"/>
   <p:notesSz cx="6858000" cy="9144000"/>
@@ -1295,6 +1296,630 @@
 </p:sldLayout>
 </file>
 
+<file path=ppt/slideLayouts/slideLayout4.xml><?xml version="1.0" encoding="utf-8"?>
+<p:sldLayout xmlns:a="http://schemas.openxmlformats.org/drawingml/2006/main" xmlns:r="http://schemas.openxmlformats.org/officeDocument/2006/relationships" xmlns:p="http://schemas.openxmlformats.org/presentationml/2006/main" preserve="1" userDrawn="1">
+  <p:cSld name="Before / After">
+    <p:spTree>
+      <p:nvGrpSpPr>
+        <p:cNvPr id="1" name=""/>
+        <p:cNvGrpSpPr/>
+        <p:nvPr/>
+      </p:nvGrpSpPr>
+      <p:grpSpPr>
+        <a:xfrm>
+          <a:off x="0" y="0"/>
+          <a:ext cx="0" cy="0"/>
+          <a:chOff x="0" y="0"/>
+          <a:chExt cx="0" cy="0"/>
+        </a:xfrm>
+      </p:grpSpPr>
+      <p:sp>
+        <p:nvSpPr>
+          <p:cNvPr id="4" name="Text Placeholder 13"/>
+          <p:cNvSpPr>
+            <a:spLocks noGrp="1"/>
+          </p:cNvSpPr>
+          <p:nvPr>
+            <p:ph type="body" sz="quarter" idx="10" hasCustomPrompt="1"/>
+          </p:nvPr>
+        </p:nvSpPr>
+        <p:spPr>
+          <a:xfrm>
+            <a:off x="4644601" y="457200"/>
+            <a:ext cx="7543800" cy="381000"/>
+          </a:xfrm>
+          <a:prstGeom prst="rect">
+            <a:avLst/>
+          </a:prstGeom>
+        </p:spPr>
+        <p:txBody>
+          <a:bodyPr/>
+          <a:lstStyle>
+            <a:lvl1pPr marL="0" indent="0" algn="r">
+              <a:lnSpc>
+                <a:spcPct val="150000"/>
+              </a:lnSpc>
+              <a:buNone/>
+              <a:defRPr sz="1500" b="0">
+                <a:solidFill>
+                  <a:schemeClr val="bg1"/>
+                </a:solidFill>
+                <a:latin typeface="+mj-lt"/>
+              </a:defRPr>
+            </a:lvl1pPr>
+            <a:lvl5pPr algn="r">
+              <a:lnSpc>
+                <a:spcPct val="150000"/>
+              </a:lnSpc>
+              <a:defRPr sz="1500" b="0">
+                <a:solidFill>
+                  <a:schemeClr val="bg1"/>
+                </a:solidFill>
+                <a:latin typeface="+mj-lt"/>
+              </a:defRPr>
+            </a:lvl5pPr>
+          </a:lstStyle>
+          <a:p>
+            <a:pPr lvl="0"/>
+            <a:r>
+              <a:rPr lang="en-US" dirty="0"/>
+              <a:t>Click to add Secondary Title</a:t>
+            </a:r>
+          </a:p>
+          <a:p>
+            <a:pPr lvl="4"/>
+            <a:endParaRPr lang="en-US" dirty="0"/>
+          </a:p>
+        </p:txBody>
+      </p:sp>
+      <p:sp>
+        <p:nvSpPr>
+          <p:cNvPr id="7" name="Title 1"/>
+          <p:cNvSpPr>
+            <a:spLocks noGrp="1"/>
+          </p:cNvSpPr>
+          <p:nvPr>
+            <p:ph type="title" hasCustomPrompt="1"/>
+          </p:nvPr>
+        </p:nvSpPr>
+        <p:spPr>
+          <a:xfrm>
+            <a:off x="4644601" y="87850"/>
+            <a:ext cx="7543800" cy="369350"/>
+          </a:xfrm>
+          <a:prstGeom prst="rect">
+            <a:avLst/>
+          </a:prstGeom>
+        </p:spPr>
+        <p:txBody>
+          <a:bodyPr>
+            <a:noAutofit/>
+          </a:bodyPr>
+          <a:lstStyle>
+            <a:lvl1pPr>
+              <a:defRPr sz="2400" spc="0">
+                <a:solidFill>
+                  <a:srgbClr val="F3F3F3"/>
+                </a:solidFill>
+                <a:effectLst>
+                  <a:outerShdw blurRad="38100" dist="38100" dir="2700000" algn="tl">
+                    <a:srgbClr val="000000">
+                      <a:alpha val="43137"/>
+                    </a:srgbClr>
+                  </a:outerShdw>
+                </a:effectLst>
+                <a:latin typeface="+mj-lt"/>
+              </a:defRPr>
+            </a:lvl1pPr>
+          </a:lstStyle>
+          <a:p>
+            <a:r>
+              <a:rPr lang="en-US" dirty="0"/>
+              <a:t>CLICK TO ADD PRIMARY TITLE</a:t>
+            </a:r>
+          </a:p>
+        </p:txBody>
+      </p:sp>
+      <p:sp>
+        <p:nvSpPr>
+          <p:cNvPr id="21" name="Before Frame"/>
+          <p:cNvSpPr txBox="1">
+            <a:spLocks noGrp="1"/>
+          </p:cNvSpPr>
+          <p:nvPr/>
+        </p:nvSpPr>
+        <p:spPr>
+          <a:xfrm>
+            <a:off x="512064" y="2331720"/>
+            <a:ext cx="5349240" cy="3081528"/>
+          </a:xfrm>
+          <a:prstGeom prst="rect">
+            <a:avLst/>
+          </a:prstGeom>
+          <a:solidFill>
+            <a:srgbClr val="F5F5F5"/>
+          </a:solidFill>
+          <a:ln w="12700">
+            <a:solidFill>
+              <a:srgbClr val="D0D0D0"/>
+            </a:solidFill>
+          </a:ln>
+        </p:spPr>
+        <p:txBody>
+          <a:bodyPr wrap="none" anchor="ctr" lIns="54864" rIns="54864" tIns="0" bIns="0">
+            <a:noAutofit/>
+          </a:bodyPr>
+          <a:lstStyle>
+            <a:lvl1pPr marL="0" indent="0" algn="l">
+              <a:buNone/>
+              <a:defRPr sz="1600" b="0">
+                <a:solidFill>
+                  <a:srgbClr val="1A1A1A"/>
+                </a:solidFill>
+                <a:latin typeface="Arial"/>
+                <a:ea typeface="PingFang SC"/>
+              </a:defRPr>
+            </a:lvl1pPr>
+          </a:lstStyle>
+          <a:p>
+            <a:pPr lvl="0" algn="l"/>
+            <a:r>
+              <a:rPr lang="zh-CN" sz="1600" b="0">
+                <a:solidFill>
+                  <a:srgbClr val="1A1A1A"/>
+                </a:solidFill>
+                <a:latin typeface="Arial"/>
+                <a:ea typeface="PingFang SC"/>
+              </a:rPr>
+              <a:t/>
+            </a:r>
+          </a:p>
+        </p:txBody>
+      </p:sp>
+      <p:sp>
+        <p:nvSpPr>
+          <p:cNvPr id="22" name="After Frame"/>
+          <p:cNvSpPr txBox="1">
+            <a:spLocks noGrp="1"/>
+          </p:cNvSpPr>
+          <p:nvPr/>
+        </p:nvSpPr>
+        <p:spPr>
+          <a:xfrm>
+            <a:off x="6327648" y="2331720"/>
+            <a:ext cx="5349240" cy="3081528"/>
+          </a:xfrm>
+          <a:prstGeom prst="rect">
+            <a:avLst/>
+          </a:prstGeom>
+          <a:solidFill>
+            <a:srgbClr val="FFFFFF"/>
+          </a:solidFill>
+          <a:ln w="12700">
+            <a:solidFill>
+              <a:srgbClr val="D0D0D0"/>
+            </a:solidFill>
+          </a:ln>
+        </p:spPr>
+        <p:txBody>
+          <a:bodyPr wrap="none" anchor="ctr" lIns="54864" rIns="54864" tIns="0" bIns="0">
+            <a:noAutofit/>
+          </a:bodyPr>
+          <a:lstStyle>
+            <a:lvl1pPr marL="0" indent="0" algn="l">
+              <a:buNone/>
+              <a:defRPr sz="1600" b="0">
+                <a:solidFill>
+                  <a:srgbClr val="1A1A1A"/>
+                </a:solidFill>
+                <a:latin typeface="Arial"/>
+                <a:ea typeface="PingFang SC"/>
+              </a:defRPr>
+            </a:lvl1pPr>
+          </a:lstStyle>
+          <a:p>
+            <a:pPr lvl="0" algn="l"/>
+            <a:r>
+              <a:rPr lang="zh-CN" sz="1600" b="0">
+                <a:solidFill>
+                  <a:srgbClr val="1A1A1A"/>
+                </a:solidFill>
+                <a:latin typeface="Arial"/>
+                <a:ea typeface="PingFang SC"/>
+              </a:rPr>
+              <a:t/>
+            </a:r>
+          </a:p>
+        </p:txBody>
+      </p:sp>
+      <p:sp>
+        <p:nvSpPr>
+          <p:cNvPr id="23" name="Conversion"/>
+          <p:cNvSpPr txBox="1">
+            <a:spLocks noGrp="1"/>
+          </p:cNvSpPr>
+          <p:nvPr/>
+        </p:nvSpPr>
+        <p:spPr>
+          <a:xfrm>
+            <a:off x="5879592" y="3584448"/>
+            <a:ext cx="429768" cy="457200"/>
+          </a:xfrm>
+          <a:prstGeom prst="rect">
+            <a:avLst/>
+          </a:prstGeom>
+          <a:noFill/>
+          <a:ln w="12700">
+            <a:noFill/>
+          </a:ln>
+        </p:spPr>
+        <p:txBody>
+          <a:bodyPr wrap="none" anchor="ctr" lIns="0" rIns="0" tIns="0" bIns="0">
+            <a:noAutofit/>
+          </a:bodyPr>
+          <a:lstStyle>
+            <a:lvl1pPr marL="0" indent="0" algn="ctr">
+              <a:buNone/>
+              <a:defRPr sz="2400" b="0">
+                <a:solidFill>
+                  <a:srgbClr val="6B6B6B"/>
+                </a:solidFill>
+                <a:latin typeface="Arial"/>
+                <a:ea typeface="PingFang SC"/>
+              </a:defRPr>
+            </a:lvl1pPr>
+          </a:lstStyle>
+          <a:p>
+            <a:pPr lvl="0" algn="ctr"/>
+            <a:r>
+              <a:rPr lang="zh-CN" sz="2400" b="0">
+                <a:solidFill>
+                  <a:srgbClr val="6B6B6B"/>
+                </a:solidFill>
+                <a:latin typeface="Arial"/>
+                <a:ea typeface="PingFang SC"/>
+              </a:rPr>
+              <a:t>→</a:t>
+            </a:r>
+          </a:p>
+        </p:txBody>
+      </p:sp>
+      <p:sp>
+        <p:nvSpPr>
+          <p:cNvPr id="25" name="Before Title"/>
+          <p:cNvSpPr txBox="1">
+            <a:spLocks noGrp="1"/>
+          </p:cNvSpPr>
+          <p:nvPr>
+            <p:ph type="body" idx="11" hasCustomPrompt="1"/>
+          </p:nvPr>
+        </p:nvSpPr>
+        <p:spPr>
+          <a:xfrm>
+            <a:off x="1860804" y="1792224"/>
+            <a:ext cx="2651760" cy="393192"/>
+          </a:xfrm>
+          <a:prstGeom prst="rect">
+            <a:avLst/>
+          </a:prstGeom>
+          <a:solidFill>
+            <a:srgbClr val="333333"/>
+          </a:solidFill>
+          <a:ln w="12700">
+            <a:noFill/>
+          </a:ln>
+        </p:spPr>
+        <p:txBody>
+          <a:bodyPr wrap="none" anchor="ctr" lIns="54864" rIns="54864" tIns="0" bIns="0">
+            <a:noAutofit/>
+          </a:bodyPr>
+          <a:lstStyle>
+            <a:lvl1pPr marL="0" indent="0" algn="ctr">
+              <a:buNone/>
+              <a:defRPr sz="2300" b="1">
+                <a:solidFill>
+                  <a:srgbClr val="FFFFFF"/>
+                </a:solidFill>
+                <a:latin typeface="Arial"/>
+                <a:ea typeface="PingFang SC"/>
+              </a:defRPr>
+            </a:lvl1pPr>
+          </a:lstStyle>
+          <a:p>
+            <a:pPr lvl="0" algn="ctr"/>
+            <a:r>
+              <a:rPr lang="zh-CN" sz="2300" b="1">
+                <a:solidFill>
+                  <a:srgbClr val="FFFFFF"/>
+                </a:solidFill>
+                <a:latin typeface="Arial"/>
+                <a:ea typeface="PingFang SC"/>
+              </a:rPr>
+              <a:t>BEFORE</a:t>
+            </a:r>
+          </a:p>
+        </p:txBody>
+      </p:sp>
+      <p:sp>
+        <p:nvSpPr>
+          <p:cNvPr id="26" name="After Title"/>
+          <p:cNvSpPr txBox="1">
+            <a:spLocks noGrp="1"/>
+          </p:cNvSpPr>
+          <p:nvPr>
+            <p:ph type="body" idx="12" hasCustomPrompt="1"/>
+          </p:nvPr>
+        </p:nvSpPr>
+        <p:spPr>
+          <a:xfrm>
+            <a:off x="7676388" y="1792224"/>
+            <a:ext cx="2651760" cy="393192"/>
+          </a:xfrm>
+          <a:prstGeom prst="rect">
+            <a:avLst/>
+          </a:prstGeom>
+          <a:solidFill>
+            <a:srgbClr val="DB011C"/>
+          </a:solidFill>
+          <a:ln w="12700">
+            <a:noFill/>
+          </a:ln>
+        </p:spPr>
+        <p:txBody>
+          <a:bodyPr wrap="none" anchor="ctr" lIns="54864" rIns="54864" tIns="0" bIns="0">
+            <a:noAutofit/>
+          </a:bodyPr>
+          <a:lstStyle>
+            <a:lvl1pPr marL="0" indent="0" algn="ctr">
+              <a:buNone/>
+              <a:defRPr sz="2300" b="1">
+                <a:solidFill>
+                  <a:srgbClr val="FFFFFF"/>
+                </a:solidFill>
+                <a:latin typeface="Arial"/>
+                <a:ea typeface="PingFang SC"/>
+              </a:defRPr>
+            </a:lvl1pPr>
+          </a:lstStyle>
+          <a:p>
+            <a:pPr lvl="0" algn="ctr"/>
+            <a:r>
+              <a:rPr lang="zh-CN" sz="2300" b="1">
+                <a:solidFill>
+                  <a:srgbClr val="FFFFFF"/>
+                </a:solidFill>
+                <a:latin typeface="Arial"/>
+                <a:ea typeface="PingFang SC"/>
+              </a:rPr>
+              <a:t>AFTER</a:t>
+            </a:r>
+          </a:p>
+        </p:txBody>
+      </p:sp>
+      <p:sp>
+        <p:nvSpPr>
+          <p:cNvPr id="27" name="Before Content"/>
+          <p:cNvSpPr txBox="1">
+            <a:spLocks noGrp="1"/>
+          </p:cNvSpPr>
+          <p:nvPr>
+            <p:ph type="body" idx="13" hasCustomPrompt="1"/>
+          </p:nvPr>
+        </p:nvSpPr>
+        <p:spPr>
+          <a:xfrm>
+            <a:off x="713232" y="2542032"/>
+            <a:ext cx="4946904" cy="2660904"/>
+          </a:xfrm>
+          <a:prstGeom prst="rect">
+            <a:avLst/>
+          </a:prstGeom>
+          <a:noFill/>
+          <a:ln w="12700">
+            <a:noFill/>
+          </a:ln>
+        </p:spPr>
+        <p:txBody>
+          <a:bodyPr wrap="none" anchor="ctr" lIns="54864" rIns="54864" tIns="0" bIns="0">
+            <a:noAutofit/>
+          </a:bodyPr>
+          <a:lstStyle>
+            <a:lvl1pPr marL="0" indent="0" algn="ctr">
+              <a:buNone/>
+              <a:defRPr sz="1800" b="0">
+                <a:solidFill>
+                  <a:srgbClr val="6B6B6B"/>
+                </a:solidFill>
+                <a:latin typeface="Arial"/>
+                <a:ea typeface="PingFang SC"/>
+              </a:defRPr>
+            </a:lvl1pPr>
+          </a:lstStyle>
+          <a:p>
+            <a:pPr lvl="0" algn="ctr"/>
+            <a:r>
+              <a:rPr lang="zh-CN" sz="1800" b="0">
+                <a:solidFill>
+                  <a:srgbClr val="6B6B6B"/>
+                </a:solidFill>
+                <a:latin typeface="Arial"/>
+                <a:ea typeface="PingFang SC"/>
+              </a:rPr>
+              <a:t>改前工作方式</a:t>
+            </a:r>
+          </a:p>
+        </p:txBody>
+      </p:sp>
+      <p:sp>
+        <p:nvSpPr>
+          <p:cNvPr id="28" name="After Content"/>
+          <p:cNvSpPr txBox="1">
+            <a:spLocks noGrp="1"/>
+          </p:cNvSpPr>
+          <p:nvPr>
+            <p:ph type="body" idx="14" hasCustomPrompt="1"/>
+          </p:nvPr>
+        </p:nvSpPr>
+        <p:spPr>
+          <a:xfrm>
+            <a:off x="6528816" y="2542032"/>
+            <a:ext cx="4946904" cy="2660904"/>
+          </a:xfrm>
+          <a:prstGeom prst="rect">
+            <a:avLst/>
+          </a:prstGeom>
+          <a:noFill/>
+          <a:ln w="12700">
+            <a:noFill/>
+          </a:ln>
+        </p:spPr>
+        <p:txBody>
+          <a:bodyPr wrap="none" anchor="ctr" lIns="54864" rIns="54864" tIns="0" bIns="0">
+            <a:noAutofit/>
+          </a:bodyPr>
+          <a:lstStyle>
+            <a:lvl1pPr marL="0" indent="0" algn="ctr">
+              <a:buNone/>
+              <a:defRPr sz="1800" b="0">
+                <a:solidFill>
+                  <a:srgbClr val="6B6B6B"/>
+                </a:solidFill>
+                <a:latin typeface="Arial"/>
+                <a:ea typeface="PingFang SC"/>
+              </a:defRPr>
+            </a:lvl1pPr>
+          </a:lstStyle>
+          <a:p>
+            <a:pPr lvl="0" algn="ctr"/>
+            <a:r>
+              <a:rPr lang="zh-CN" sz="1800" b="0">
+                <a:solidFill>
+                  <a:srgbClr val="6B6B6B"/>
+                </a:solidFill>
+                <a:latin typeface="Arial"/>
+                <a:ea typeface="PingFang SC"/>
+              </a:rPr>
+              <a:t>改后工作方式</a:t>
+            </a:r>
+          </a:p>
+        </p:txBody>
+      </p:sp>
+      <p:sp>
+        <p:nvSpPr>
+          <p:cNvPr id="29" name="Before Caption"/>
+          <p:cNvSpPr txBox="1">
+            <a:spLocks noGrp="1"/>
+          </p:cNvSpPr>
+          <p:nvPr>
+            <p:ph type="body" idx="15" hasCustomPrompt="1"/>
+          </p:nvPr>
+        </p:nvSpPr>
+        <p:spPr>
+          <a:xfrm>
+            <a:off x="512064" y="5596128"/>
+            <a:ext cx="5349240" cy="320040"/>
+          </a:xfrm>
+          <a:prstGeom prst="rect">
+            <a:avLst/>
+          </a:prstGeom>
+          <a:noFill/>
+          <a:ln w="12700">
+            <a:noFill/>
+          </a:ln>
+        </p:spPr>
+        <p:txBody>
+          <a:bodyPr wrap="none" anchor="ctr" lIns="54864" rIns="54864" tIns="0" bIns="0">
+            <a:noAutofit/>
+          </a:bodyPr>
+          <a:lstStyle>
+            <a:lvl1pPr marL="0" indent="0" algn="l">
+              <a:buNone/>
+              <a:defRPr sz="1600" b="1">
+                <a:solidFill>
+                  <a:srgbClr val="1A1A1A"/>
+                </a:solidFill>
+                <a:latin typeface="Arial"/>
+                <a:ea typeface="PingFang SC"/>
+              </a:defRPr>
+            </a:lvl1pPr>
+          </a:lstStyle>
+          <a:p>
+            <a:pPr lvl="0" algn="l"/>
+            <a:r>
+              <a:rPr lang="zh-CN" sz="1600" b="1">
+                <a:solidFill>
+                  <a:srgbClr val="1A1A1A"/>
+                </a:solidFill>
+                <a:latin typeface="Arial"/>
+                <a:ea typeface="PingFang SC"/>
+              </a:rPr>
+              <a:t>一句说明</a:t>
+            </a:r>
+          </a:p>
+        </p:txBody>
+      </p:sp>
+      <p:sp>
+        <p:nvSpPr>
+          <p:cNvPr id="30" name="After Caption"/>
+          <p:cNvSpPr txBox="1">
+            <a:spLocks noGrp="1"/>
+          </p:cNvSpPr>
+          <p:nvPr>
+            <p:ph type="body" idx="16" hasCustomPrompt="1"/>
+          </p:nvPr>
+        </p:nvSpPr>
+        <p:spPr>
+          <a:xfrm>
+            <a:off x="6327648" y="5596128"/>
+            <a:ext cx="5349240" cy="320040"/>
+          </a:xfrm>
+          <a:prstGeom prst="rect">
+            <a:avLst/>
+          </a:prstGeom>
+          <a:noFill/>
+          <a:ln w="12700">
+            <a:noFill/>
+          </a:ln>
+        </p:spPr>
+        <p:txBody>
+          <a:bodyPr wrap="none" anchor="ctr" lIns="54864" rIns="54864" tIns="0" bIns="0">
+            <a:noAutofit/>
+          </a:bodyPr>
+          <a:lstStyle>
+            <a:lvl1pPr marL="0" indent="0" algn="l">
+              <a:buNone/>
+              <a:defRPr sz="1600" b="1">
+                <a:solidFill>
+                  <a:srgbClr val="1A1A1A"/>
+                </a:solidFill>
+                <a:latin typeface="Arial"/>
+                <a:ea typeface="PingFang SC"/>
+              </a:defRPr>
+            </a:lvl1pPr>
+          </a:lstStyle>
+          <a:p>
+            <a:pPr lvl="0" algn="l"/>
+            <a:r>
+              <a:rPr lang="zh-CN" sz="1600" b="1">
+                <a:solidFill>
+                  <a:srgbClr val="1A1A1A"/>
+                </a:solidFill>
+                <a:latin typeface="Arial"/>
+                <a:ea typeface="PingFang SC"/>
+              </a:rPr>
+              <a:t>一句说明</a:t>
+            </a:r>
+          </a:p>
+        </p:txBody>
+      </p:sp>
+    </p:spTree>
+  </p:cSld>
+  <p:clrMapOvr>
+    <a:masterClrMapping/>
+  </p:clrMapOvr>
+</p:sldLayout>
+</file>
+
 <file path=ppt/slideMasters/slideMaster1.xml><?xml version="1.0" encoding="utf-8"?>
 <p:sldMaster xmlns:a="http://schemas.openxmlformats.org/drawingml/2006/main" xmlns:r="http://schemas.openxmlformats.org/officeDocument/2006/relationships" xmlns:p="http://schemas.openxmlformats.org/presentationml/2006/main">
   <p:cSld>
@@ -1506,6 +2131,7 @@
     <p:sldLayoutId id="2147483661" r:id="rId1"/>
     <p:sldLayoutId id="2147483687" r:id="rId2"/>
     <p:sldLayoutId id="2147483688" r:id="rId3"/>
+    <p:sldLayoutId id="2147483689" r:id="rId6"/>
   </p:sldLayoutIdLst>
   <p:transition>
     <p:fade thruBlk="1"/>
@@ -2297,6 +2923,567 @@
   <p:transition>
     <p:fade thruBlk="1"/>
   </p:transition>
+</p:sld>
+</file>
+
+<file path=ppt/slides/slide4.xml><?xml version="1.0" encoding="utf-8"?>
+<p:sld xmlns:a="http://schemas.openxmlformats.org/drawingml/2006/main" xmlns:r="http://schemas.openxmlformats.org/officeDocument/2006/relationships" xmlns:p="http://schemas.openxmlformats.org/presentationml/2006/main">
+  <p:cSld>
+    <p:spTree>
+      <p:nvGrpSpPr>
+        <p:cNvPr id="1" name=""/>
+        <p:cNvGrpSpPr/>
+        <p:nvPr/>
+      </p:nvGrpSpPr>
+      <p:grpSpPr>
+        <a:xfrm>
+          <a:off x="0" y="0"/>
+          <a:ext cx="0" cy="0"/>
+          <a:chOff x="0" y="0"/>
+          <a:chExt cx="0" cy="0"/>
+        </a:xfrm>
+      </p:grpSpPr>
+      <p:sp>
+        <p:nvSpPr>
+          <p:cNvPr id="20" name="Lead"/>
+          <p:cNvSpPr txBox="1">
+            <a:spLocks noGrp="1"/>
+          </p:cNvSpPr>
+          <p:nvPr/>
+        </p:nvSpPr>
+        <p:spPr>
+          <a:xfrm>
+            <a:off x="512064" y="1188720"/>
+            <a:ext cx="10881360" cy="384048"/>
+          </a:xfrm>
+          <a:prstGeom prst="rect">
+            <a:avLst/>
+          </a:prstGeom>
+          <a:noFill/>
+          <a:ln w="12700">
+            <a:noFill/>
+          </a:ln>
+        </p:spPr>
+        <p:txBody>
+          <a:bodyPr wrap="none" anchor="ctr" lIns="54864" rIns="54864" tIns="0" bIns="0">
+            <a:noAutofit/>
+          </a:bodyPr>
+          <a:lstStyle>
+            <a:lvl1pPr marL="0" indent="0" algn="l">
+              <a:buNone/>
+              <a:defRPr sz="2000" b="1">
+                <a:solidFill>
+                  <a:srgbClr val="1A1A1A"/>
+                </a:solidFill>
+                <a:latin typeface="Arial"/>
+                <a:ea typeface="PingFang SC"/>
+              </a:defRPr>
+            </a:lvl1pPr>
+          </a:lstStyle>
+          <a:p>
+            <a:pPr lvl="0" algn="l"/>
+            <a:r>
+              <a:rPr lang="zh-CN" sz="2000" b="1">
+                <a:solidFill>
+                  <a:srgbClr val="1A1A1A"/>
+                </a:solidFill>
+                <a:latin typeface="Arial"/>
+                <a:ea typeface="PingFang SC"/>
+              </a:rPr>
+              <a:t>结论与证据</a:t>
+            </a:r>
+          </a:p>
+        </p:txBody>
+      </p:sp>
+      <p:sp>
+        <p:nvSpPr>
+          <p:cNvPr id="24" name="Conclusion"/>
+          <p:cNvSpPr txBox="1">
+            <a:spLocks noGrp="1"/>
+          </p:cNvSpPr>
+          <p:nvPr/>
+        </p:nvSpPr>
+        <p:spPr>
+          <a:xfrm>
+            <a:off x="512064" y="6108192"/>
+            <a:ext cx="11164824" cy="329184"/>
+          </a:xfrm>
+          <a:prstGeom prst="rect">
+            <a:avLst/>
+          </a:prstGeom>
+          <a:solidFill>
+            <a:srgbClr val="F5F5F5"/>
+          </a:solidFill>
+          <a:ln w="12700">
+            <a:noFill/>
+          </a:ln>
+        </p:spPr>
+        <p:txBody>
+          <a:bodyPr wrap="none" anchor="ctr" lIns="109728" rIns="109728" tIns="0" bIns="0">
+            <a:noAutofit/>
+          </a:bodyPr>
+          <a:lstStyle>
+            <a:lvl1pPr marL="0" indent="0" algn="l">
+              <a:buNone/>
+              <a:defRPr sz="1400" b="0">
+                <a:solidFill>
+                  <a:srgbClr val="1A1A1A"/>
+                </a:solidFill>
+                <a:latin typeface="Arial"/>
+                <a:ea typeface="PingFang SC"/>
+              </a:defRPr>
+            </a:lvl1pPr>
+          </a:lstStyle>
+          <a:p>
+            <a:pPr lvl="0" algn="l"/>
+            <a:r>
+              <a:rPr lang="zh-CN" sz="1400" b="0">
+                <a:solidFill>
+                  <a:srgbClr val="1A1A1A"/>
+                </a:solidFill>
+                <a:latin typeface="Arial"/>
+                <a:ea typeface="PingFang SC"/>
+              </a:rPr>
+              <a:t>结论占位：按证据填写</a:t>
+            </a:r>
+          </a:p>
+        </p:txBody>
+      </p:sp>
+      <p:sp>
+        <p:nvSpPr>
+          <p:cNvPr id="4" name="Text Placeholder 13"/>
+          <p:cNvSpPr>
+            <a:spLocks noGrp="1"/>
+          </p:cNvSpPr>
+          <p:nvPr>
+            <p:ph type="body" sz="quarter" idx="10" hasCustomPrompt="1"/>
+          </p:nvPr>
+        </p:nvSpPr>
+        <p:spPr>
+          <a:xfrm>
+            <a:off x="4644601" y="457200"/>
+            <a:ext cx="7543800" cy="381000"/>
+          </a:xfrm>
+          <a:prstGeom prst="rect">
+            <a:avLst/>
+          </a:prstGeom>
+        </p:spPr>
+        <p:txBody>
+          <a:bodyPr/>
+          <a:lstStyle>
+            <a:lvl1pPr marL="0" indent="0" algn="r">
+              <a:lnSpc>
+                <a:spcPct val="150000"/>
+              </a:lnSpc>
+              <a:buNone/>
+              <a:defRPr sz="1500" b="0">
+                <a:solidFill>
+                  <a:schemeClr val="bg1"/>
+                </a:solidFill>
+                <a:latin typeface="+mj-lt"/>
+              </a:defRPr>
+            </a:lvl1pPr>
+            <a:lvl5pPr algn="r">
+              <a:lnSpc>
+                <a:spcPct val="150000"/>
+              </a:lnSpc>
+              <a:defRPr sz="1500" b="0">
+                <a:solidFill>
+                  <a:schemeClr val="bg1"/>
+                </a:solidFill>
+                <a:latin typeface="+mj-lt"/>
+              </a:defRPr>
+            </a:lvl5pPr>
+          </a:lstStyle>
+          <a:p>
+            <a:r>
+              <a:rPr lang="zh-CN"/>
+              <a:t>用对应事实说明改前与改后</a:t>
+            </a:r>
+          </a:p>
+        </p:txBody>
+      </p:sp>
+      <p:sp>
+        <p:nvSpPr>
+          <p:cNvPr id="7" name="Title 1"/>
+          <p:cNvSpPr>
+            <a:spLocks noGrp="1"/>
+          </p:cNvSpPr>
+          <p:nvPr>
+            <p:ph type="title" hasCustomPrompt="1"/>
+          </p:nvPr>
+        </p:nvSpPr>
+        <p:spPr>
+          <a:xfrm>
+            <a:off x="4644601" y="87850"/>
+            <a:ext cx="7543800" cy="369350"/>
+          </a:xfrm>
+          <a:prstGeom prst="rect">
+            <a:avLst/>
+          </a:prstGeom>
+        </p:spPr>
+        <p:txBody>
+          <a:bodyPr>
+            <a:noAutofit/>
+          </a:bodyPr>
+          <a:lstStyle>
+            <a:lvl1pPr>
+              <a:defRPr sz="2400" spc="0">
+                <a:solidFill>
+                  <a:srgbClr val="F3F3F3"/>
+                </a:solidFill>
+                <a:effectLst>
+                  <a:outerShdw blurRad="38100" dist="38100" dir="2700000" algn="tl">
+                    <a:srgbClr val="000000">
+                      <a:alpha val="43137"/>
+                    </a:srgbClr>
+                  </a:outerShdw>
+                </a:effectLst>
+                <a:latin typeface="+mj-lt"/>
+              </a:defRPr>
+            </a:lvl1pPr>
+          </a:lstStyle>
+          <a:p>
+            <a:r>
+              <a:rPr lang="zh-CN"/>
+              <a:t>工作方式对比</a:t>
+            </a:r>
+          </a:p>
+        </p:txBody>
+      </p:sp>
+      <p:sp>
+        <p:nvSpPr>
+          <p:cNvPr id="25" name="Before Title"/>
+          <p:cNvSpPr txBox="1">
+            <a:spLocks noGrp="1"/>
+          </p:cNvSpPr>
+          <p:nvPr>
+            <p:ph type="body" idx="11" hasCustomPrompt="1"/>
+          </p:nvPr>
+        </p:nvSpPr>
+        <p:spPr>
+          <a:xfrm>
+            <a:off x="1860804" y="1792224"/>
+            <a:ext cx="2651760" cy="393192"/>
+          </a:xfrm>
+          <a:prstGeom prst="rect">
+            <a:avLst/>
+          </a:prstGeom>
+          <a:solidFill>
+            <a:srgbClr val="333333"/>
+          </a:solidFill>
+          <a:ln w="12700">
+            <a:noFill/>
+          </a:ln>
+        </p:spPr>
+        <p:txBody>
+          <a:bodyPr wrap="none" anchor="ctr" lIns="54864" rIns="54864" tIns="0" bIns="0">
+            <a:noAutofit/>
+          </a:bodyPr>
+          <a:lstStyle>
+            <a:lvl1pPr marL="0" indent="0" algn="ctr">
+              <a:buNone/>
+              <a:defRPr sz="2300" b="1">
+                <a:solidFill>
+                  <a:srgbClr val="FFFFFF"/>
+                </a:solidFill>
+                <a:latin typeface="Arial"/>
+                <a:ea typeface="PingFang SC"/>
+              </a:defRPr>
+            </a:lvl1pPr>
+          </a:lstStyle>
+          <a:p>
+            <a:pPr lvl="0" algn="ctr"/>
+            <a:r>
+              <a:rPr lang="zh-CN" sz="2300" b="1">
+                <a:solidFill>
+                  <a:srgbClr val="FFFFFF"/>
+                </a:solidFill>
+                <a:latin typeface="Arial"/>
+                <a:ea typeface="PingFang SC"/>
+              </a:rPr>
+              <a:t>BEFORE</a:t>
+            </a:r>
+          </a:p>
+        </p:txBody>
+      </p:sp>
+      <p:sp>
+        <p:nvSpPr>
+          <p:cNvPr id="26" name="After Title"/>
+          <p:cNvSpPr txBox="1">
+            <a:spLocks noGrp="1"/>
+          </p:cNvSpPr>
+          <p:nvPr>
+            <p:ph type="body" idx="12" hasCustomPrompt="1"/>
+          </p:nvPr>
+        </p:nvSpPr>
+        <p:spPr>
+          <a:xfrm>
+            <a:off x="7676388" y="1792224"/>
+            <a:ext cx="2651760" cy="393192"/>
+          </a:xfrm>
+          <a:prstGeom prst="rect">
+            <a:avLst/>
+          </a:prstGeom>
+          <a:solidFill>
+            <a:srgbClr val="DB011C"/>
+          </a:solidFill>
+          <a:ln w="12700">
+            <a:noFill/>
+          </a:ln>
+        </p:spPr>
+        <p:txBody>
+          <a:bodyPr wrap="none" anchor="ctr" lIns="54864" rIns="54864" tIns="0" bIns="0">
+            <a:noAutofit/>
+          </a:bodyPr>
+          <a:lstStyle>
+            <a:lvl1pPr marL="0" indent="0" algn="ctr">
+              <a:buNone/>
+              <a:defRPr sz="2300" b="1">
+                <a:solidFill>
+                  <a:srgbClr val="FFFFFF"/>
+                </a:solidFill>
+                <a:latin typeface="Arial"/>
+                <a:ea typeface="PingFang SC"/>
+              </a:defRPr>
+            </a:lvl1pPr>
+          </a:lstStyle>
+          <a:p>
+            <a:pPr lvl="0" algn="ctr"/>
+            <a:r>
+              <a:rPr lang="zh-CN" sz="2300" b="1">
+                <a:solidFill>
+                  <a:srgbClr val="FFFFFF"/>
+                </a:solidFill>
+                <a:latin typeface="Arial"/>
+                <a:ea typeface="PingFang SC"/>
+              </a:rPr>
+              <a:t>AFTER</a:t>
+            </a:r>
+          </a:p>
+        </p:txBody>
+      </p:sp>
+      <p:sp>
+        <p:nvSpPr>
+          <p:cNvPr id="27" name="Before Content"/>
+          <p:cNvSpPr txBox="1">
+            <a:spLocks noGrp="1"/>
+          </p:cNvSpPr>
+          <p:nvPr>
+            <p:ph type="body" idx="13" hasCustomPrompt="1"/>
+          </p:nvPr>
+        </p:nvSpPr>
+        <p:spPr>
+          <a:xfrm>
+            <a:off x="713232" y="2542032"/>
+            <a:ext cx="4946904" cy="2660904"/>
+          </a:xfrm>
+          <a:prstGeom prst="rect">
+            <a:avLst/>
+          </a:prstGeom>
+          <a:noFill/>
+          <a:ln w="12700">
+            <a:noFill/>
+          </a:ln>
+        </p:spPr>
+        <p:txBody>
+          <a:bodyPr wrap="none" anchor="ctr" lIns="54864" rIns="54864" tIns="0" bIns="0">
+            <a:noAutofit/>
+          </a:bodyPr>
+          <a:lstStyle>
+            <a:lvl1pPr marL="0" indent="0" algn="ctr">
+              <a:buNone/>
+              <a:defRPr sz="1800" b="0">
+                <a:solidFill>
+                  <a:srgbClr val="6B6B6B"/>
+                </a:solidFill>
+                <a:latin typeface="Arial"/>
+                <a:ea typeface="PingFang SC"/>
+              </a:defRPr>
+            </a:lvl1pPr>
+          </a:lstStyle>
+          <a:p>
+            <a:pPr lvl="0" algn="ctr"/>
+            <a:r>
+              <a:rPr lang="zh-CN" sz="1800" b="0">
+                <a:solidFill>
+                  <a:srgbClr val="6B6B6B"/>
+                </a:solidFill>
+                <a:latin typeface="Arial"/>
+                <a:ea typeface="PingFang SC"/>
+              </a:rPr>
+              <a:t>改前工作方式</a:t>
+            </a:r>
+          </a:p>
+        </p:txBody>
+      </p:sp>
+      <p:sp>
+        <p:nvSpPr>
+          <p:cNvPr id="28" name="After Content"/>
+          <p:cNvSpPr txBox="1">
+            <a:spLocks noGrp="1"/>
+          </p:cNvSpPr>
+          <p:nvPr>
+            <p:ph type="body" idx="14" hasCustomPrompt="1"/>
+          </p:nvPr>
+        </p:nvSpPr>
+        <p:spPr>
+          <a:xfrm>
+            <a:off x="6528816" y="2542032"/>
+            <a:ext cx="4946904" cy="2660904"/>
+          </a:xfrm>
+          <a:prstGeom prst="rect">
+            <a:avLst/>
+          </a:prstGeom>
+          <a:noFill/>
+          <a:ln w="12700">
+            <a:noFill/>
+          </a:ln>
+        </p:spPr>
+        <p:txBody>
+          <a:bodyPr wrap="none" anchor="ctr" lIns="54864" rIns="54864" tIns="0" bIns="0">
+            <a:noAutofit/>
+          </a:bodyPr>
+          <a:lstStyle>
+            <a:lvl1pPr marL="0" indent="0" algn="ctr">
+              <a:buNone/>
+              <a:defRPr sz="1800" b="0">
+                <a:solidFill>
+                  <a:srgbClr val="6B6B6B"/>
+                </a:solidFill>
+                <a:latin typeface="Arial"/>
+                <a:ea typeface="PingFang SC"/>
+              </a:defRPr>
+            </a:lvl1pPr>
+          </a:lstStyle>
+          <a:p>
+            <a:pPr lvl="0" algn="ctr"/>
+            <a:r>
+              <a:rPr lang="zh-CN" sz="1800" b="0">
+                <a:solidFill>
+                  <a:srgbClr val="6B6B6B"/>
+                </a:solidFill>
+                <a:latin typeface="Arial"/>
+                <a:ea typeface="PingFang SC"/>
+              </a:rPr>
+              <a:t>改后工作方式</a:t>
+            </a:r>
+          </a:p>
+        </p:txBody>
+      </p:sp>
+      <p:sp>
+        <p:nvSpPr>
+          <p:cNvPr id="29" name="Before Caption"/>
+          <p:cNvSpPr txBox="1">
+            <a:spLocks noGrp="1"/>
+          </p:cNvSpPr>
+          <p:nvPr>
+            <p:ph type="body" idx="15" hasCustomPrompt="1"/>
+          </p:nvPr>
+        </p:nvSpPr>
+        <p:spPr>
+          <a:xfrm>
+            <a:off x="512064" y="5596128"/>
+            <a:ext cx="5349240" cy="320040"/>
+          </a:xfrm>
+          <a:prstGeom prst="rect">
+            <a:avLst/>
+          </a:prstGeom>
+          <a:noFill/>
+          <a:ln w="12700">
+            <a:noFill/>
+          </a:ln>
+        </p:spPr>
+        <p:txBody>
+          <a:bodyPr wrap="none" anchor="ctr" lIns="54864" rIns="54864" tIns="0" bIns="0">
+            <a:noAutofit/>
+          </a:bodyPr>
+          <a:lstStyle>
+            <a:lvl1pPr marL="0" indent="0" algn="l">
+              <a:buNone/>
+              <a:defRPr sz="1600" b="1">
+                <a:solidFill>
+                  <a:srgbClr val="1A1A1A"/>
+                </a:solidFill>
+                <a:latin typeface="Arial"/>
+                <a:ea typeface="PingFang SC"/>
+              </a:defRPr>
+            </a:lvl1pPr>
+          </a:lstStyle>
+          <a:p>
+            <a:pPr lvl="0" algn="l"/>
+            <a:r>
+              <a:rPr lang="zh-CN" sz="1600" b="1">
+                <a:solidFill>
+                  <a:srgbClr val="1A1A1A"/>
+                </a:solidFill>
+                <a:latin typeface="Arial"/>
+                <a:ea typeface="PingFang SC"/>
+              </a:rPr>
+              <a:t>一句说明</a:t>
+            </a:r>
+          </a:p>
+        </p:txBody>
+      </p:sp>
+      <p:sp>
+        <p:nvSpPr>
+          <p:cNvPr id="30" name="After Caption"/>
+          <p:cNvSpPr txBox="1">
+            <a:spLocks noGrp="1"/>
+          </p:cNvSpPr>
+          <p:nvPr>
+            <p:ph type="body" idx="16" hasCustomPrompt="1"/>
+          </p:nvPr>
+        </p:nvSpPr>
+        <p:spPr>
+          <a:xfrm>
+            <a:off x="6327648" y="5596128"/>
+            <a:ext cx="5349240" cy="320040"/>
+          </a:xfrm>
+          <a:prstGeom prst="rect">
+            <a:avLst/>
+          </a:prstGeom>
+          <a:noFill/>
+          <a:ln w="12700">
+            <a:noFill/>
+          </a:ln>
+        </p:spPr>
+        <p:txBody>
+          <a:bodyPr wrap="none" anchor="ctr" lIns="54864" rIns="54864" tIns="0" bIns="0">
+            <a:noAutofit/>
+          </a:bodyPr>
+          <a:lstStyle>
+            <a:lvl1pPr marL="0" indent="0" algn="l">
+              <a:buNone/>
+              <a:defRPr sz="1600" b="1">
+                <a:solidFill>
+                  <a:srgbClr val="1A1A1A"/>
+                </a:solidFill>
+                <a:latin typeface="Arial"/>
+                <a:ea typeface="PingFang SC"/>
+              </a:defRPr>
+            </a:lvl1pPr>
+          </a:lstStyle>
+          <a:p>
+            <a:pPr lvl="0" algn="l"/>
+            <a:r>
+              <a:rPr lang="zh-CN" sz="1600" b="1">
+                <a:solidFill>
+                  <a:srgbClr val="1A1A1A"/>
+                </a:solidFill>
+                <a:latin typeface="Arial"/>
+                <a:ea typeface="PingFang SC"/>
+              </a:rPr>
+              <a:t>一句说明</a:t>
+            </a:r>
+          </a:p>
+        </p:txBody>
+      </p:sp>
+    </p:spTree>
+  </p:cSld>
+  <p:clrMapOvr>
+    <a:masterClrMapping/>
+  </p:clrMapOvr>
 </p:sld>
 </file>
 

</xml_diff>

<commit_message>
milwaukee-ppt：模板追加 layout 4–7（Process / Stats / Timeline / Image + Text）与版式契约测试
- 新 layout 沿用 layout 0 的 idx 0/10，正文区为命名 BODY 定位槽（idx 17–21），不预画形状、不加红色
- 槽位统一落在 0.56–12.77 × 1.30–5.60 英寸（左右边距 0.56，块间距 0.3，底边让出证据页红条）
- layout 0–3 与 4 张样例页保持不变；tests/test_template_layouts.py 以 e2cbdea 为基线比对

Co-Authored-By: Claude <noreply@anthropic.com>
</commit_message>
<xml_diff>
--- a/skills/milwaukee-ppt/assets/MS_Template.pptx
+++ b/skills/milwaukee-ppt/assets/MS_Template.pptx
@@ -1920,6 +1920,827 @@
 </p:sldLayout>
 </file>
 
+<file path=ppt/slideLayouts/slideLayout5.xml><?xml version="1.0" encoding="utf-8"?>
+<p:sldLayout xmlns:a="http://schemas.openxmlformats.org/drawingml/2006/main" xmlns:r="http://schemas.openxmlformats.org/officeDocument/2006/relationships" xmlns:p="http://schemas.openxmlformats.org/presentationml/2006/main" preserve="1" userDrawn="1">
+  <p:cSld name="Process">
+    <p:spTree>
+      <p:nvGrpSpPr>
+        <p:cNvPr id="1" name=""/>
+        <p:cNvGrpSpPr/>
+        <p:nvPr/>
+      </p:nvGrpSpPr>
+      <p:grpSpPr>
+        <a:xfrm>
+          <a:off x="0" y="0"/>
+          <a:ext cx="0" cy="0"/>
+          <a:chOff x="0" y="0"/>
+          <a:chExt cx="0" cy="0"/>
+        </a:xfrm>
+      </p:grpSpPr>
+      <p:sp>
+        <p:nvSpPr>
+          <p:cNvPr id="4" name="Text Placeholder 13"/>
+          <p:cNvSpPr>
+            <a:spLocks noGrp="1"/>
+          </p:cNvSpPr>
+          <p:nvPr>
+            <p:ph type="body" sz="quarter" idx="10" hasCustomPrompt="1"/>
+          </p:nvPr>
+        </p:nvSpPr>
+        <p:spPr>
+          <a:xfrm>
+            <a:off x="4644601" y="457200"/>
+            <a:ext cx="7543800" cy="381000"/>
+          </a:xfrm>
+          <a:prstGeom prst="rect">
+            <a:avLst/>
+          </a:prstGeom>
+        </p:spPr>
+        <p:txBody>
+          <a:bodyPr/>
+          <a:lstStyle>
+            <a:lvl1pPr marL="0" indent="0" algn="r">
+              <a:lnSpc>
+                <a:spcPct val="150000"/>
+              </a:lnSpc>
+              <a:buNone/>
+              <a:defRPr sz="1500" b="0">
+                <a:solidFill>
+                  <a:schemeClr val="bg1"/>
+                </a:solidFill>
+                <a:latin typeface="+mj-lt"/>
+              </a:defRPr>
+            </a:lvl1pPr>
+            <a:lvl5pPr algn="r">
+              <a:lnSpc>
+                <a:spcPct val="150000"/>
+              </a:lnSpc>
+              <a:defRPr sz="1500" b="0">
+                <a:solidFill>
+                  <a:schemeClr val="bg1"/>
+                </a:solidFill>
+                <a:latin typeface="+mj-lt"/>
+              </a:defRPr>
+            </a:lvl5pPr>
+          </a:lstStyle>
+          <a:p>
+            <a:pPr lvl="0"/>
+            <a:r>
+              <a:rPr lang="en-US" dirty="0"/>
+              <a:t>Click to add Secondary Title</a:t>
+            </a:r>
+          </a:p>
+          <a:p>
+            <a:pPr lvl="4"/>
+            <a:endParaRPr lang="en-US" dirty="0"/>
+          </a:p>
+        </p:txBody>
+      </p:sp>
+      <p:sp>
+        <p:nvSpPr>
+          <p:cNvPr id="7" name="Title 1"/>
+          <p:cNvSpPr>
+            <a:spLocks noGrp="1"/>
+          </p:cNvSpPr>
+          <p:nvPr>
+            <p:ph type="title" hasCustomPrompt="1"/>
+          </p:nvPr>
+        </p:nvSpPr>
+        <p:spPr>
+          <a:xfrm>
+            <a:off x="4644601" y="87850"/>
+            <a:ext cx="7543800" cy="369350"/>
+          </a:xfrm>
+          <a:prstGeom prst="rect">
+            <a:avLst/>
+          </a:prstGeom>
+        </p:spPr>
+        <p:txBody>
+          <a:bodyPr>
+            <a:noAutofit/>
+          </a:bodyPr>
+          <a:lstStyle>
+            <a:lvl1pPr>
+              <a:defRPr sz="2400" spc="0">
+                <a:solidFill>
+                  <a:srgbClr val="F3F3F3"/>
+                </a:solidFill>
+                <a:effectLst>
+                  <a:outerShdw blurRad="38100" dist="38100" dir="2700000" algn="tl">
+                    <a:srgbClr val="000000">
+                      <a:alpha val="43137"/>
+                    </a:srgbClr>
+                  </a:outerShdw>
+                </a:effectLst>
+                <a:latin typeface="+mj-lt"/>
+              </a:defRPr>
+            </a:lvl1pPr>
+          </a:lstStyle>
+          <a:p>
+            <a:r>
+              <a:rPr lang="en-US" dirty="0"/>
+              <a:t>CLICK TO ADD PRIMARY TITLE</a:t>
+            </a:r>
+          </a:p>
+        </p:txBody>
+      </p:sp>
+      <p:sp>
+        <p:nvSpPr>
+          <p:cNvPr id="8" name="Process Area"/>
+          <p:cNvSpPr>
+            <a:spLocks noGrp="1"/>
+          </p:cNvSpPr>
+          <p:nvPr>
+            <p:ph type="body" sz="quarter" idx="17" hasCustomPrompt="1"/>
+          </p:nvPr>
+        </p:nvSpPr>
+        <p:spPr>
+          <a:xfrm>
+            <a:off x="512064" y="1188720"/>
+            <a:ext cx="11164824" cy="3931920"/>
+          </a:xfrm>
+          <a:prstGeom prst="rect">
+            <a:avLst/>
+          </a:prstGeom>
+          <a:noFill/>
+          <a:ln>
+            <a:noFill/>
+          </a:ln>
+        </p:spPr>
+        <p:txBody>
+          <a:bodyPr wrap="square" lIns="0" tIns="0" rIns="0" bIns="0" anchor="ctr">
+            <a:noAutofit/>
+          </a:bodyPr>
+          <a:lstStyle>
+            <a:lvl1pPr marL="0" indent="0" algn="ctr">
+              <a:spcBef>
+                <a:spcPts val="0"/>
+              </a:spcBef>
+              <a:buNone/>
+              <a:defRPr sz="1400" b="0">
+                <a:solidFill>
+                  <a:srgbClr val="6B6B6B"/>
+                </a:solidFill>
+                <a:latin typeface="Arial"/>
+                <a:ea typeface="PingFang SC"/>
+              </a:defRPr>
+            </a:lvl1pPr>
+          </a:lstStyle>
+          <a:p>
+            <a:r>
+              <a:rPr lang="zh-CN" dirty="0"/>
+              <a:t>流程区：生成器按步骤数（3–5）等分绘制卡片</a:t>
+            </a:r>
+          </a:p>
+        </p:txBody>
+      </p:sp>
+    </p:spTree>
+    <p:extLst>
+      <p:ext uri="{BB962C8B-B14F-4D97-AF65-F5344CB8AC3E}">
+        <p14:creationId xmlns:p14="http://schemas.microsoft.com/office/powerpoint/2010/main" val="864985971"/>
+      </p:ext>
+    </p:extLst>
+  </p:cSld>
+  <p:clrMapOvr>
+    <a:masterClrMapping/>
+  </p:clrMapOvr>
+  <p:transition>
+    <p:fade thruBlk="1"/>
+  </p:transition>
+</p:sldLayout>
+</file>
+
+<file path=ppt/slideLayouts/slideLayout6.xml><?xml version="1.0" encoding="utf-8"?>
+<p:sldLayout xmlns:a="http://schemas.openxmlformats.org/drawingml/2006/main" xmlns:r="http://schemas.openxmlformats.org/officeDocument/2006/relationships" xmlns:p="http://schemas.openxmlformats.org/presentationml/2006/main" preserve="1" userDrawn="1">
+  <p:cSld name="Stats">
+    <p:spTree>
+      <p:nvGrpSpPr>
+        <p:cNvPr id="1" name=""/>
+        <p:cNvGrpSpPr/>
+        <p:nvPr/>
+      </p:nvGrpSpPr>
+      <p:grpSpPr>
+        <a:xfrm>
+          <a:off x="0" y="0"/>
+          <a:ext cx="0" cy="0"/>
+          <a:chOff x="0" y="0"/>
+          <a:chExt cx="0" cy="0"/>
+        </a:xfrm>
+      </p:grpSpPr>
+      <p:sp>
+        <p:nvSpPr>
+          <p:cNvPr id="4" name="Text Placeholder 13"/>
+          <p:cNvSpPr>
+            <a:spLocks noGrp="1"/>
+          </p:cNvSpPr>
+          <p:nvPr>
+            <p:ph type="body" sz="quarter" idx="10" hasCustomPrompt="1"/>
+          </p:nvPr>
+        </p:nvSpPr>
+        <p:spPr>
+          <a:xfrm>
+            <a:off x="4644601" y="457200"/>
+            <a:ext cx="7543800" cy="381000"/>
+          </a:xfrm>
+          <a:prstGeom prst="rect">
+            <a:avLst/>
+          </a:prstGeom>
+        </p:spPr>
+        <p:txBody>
+          <a:bodyPr/>
+          <a:lstStyle>
+            <a:lvl1pPr marL="0" indent="0" algn="r">
+              <a:lnSpc>
+                <a:spcPct val="150000"/>
+              </a:lnSpc>
+              <a:buNone/>
+              <a:defRPr sz="1500" b="0">
+                <a:solidFill>
+                  <a:schemeClr val="bg1"/>
+                </a:solidFill>
+                <a:latin typeface="+mj-lt"/>
+              </a:defRPr>
+            </a:lvl1pPr>
+            <a:lvl5pPr algn="r">
+              <a:lnSpc>
+                <a:spcPct val="150000"/>
+              </a:lnSpc>
+              <a:defRPr sz="1500" b="0">
+                <a:solidFill>
+                  <a:schemeClr val="bg1"/>
+                </a:solidFill>
+                <a:latin typeface="+mj-lt"/>
+              </a:defRPr>
+            </a:lvl5pPr>
+          </a:lstStyle>
+          <a:p>
+            <a:pPr lvl="0"/>
+            <a:r>
+              <a:rPr lang="en-US" dirty="0"/>
+              <a:t>Click to add Secondary Title</a:t>
+            </a:r>
+          </a:p>
+          <a:p>
+            <a:pPr lvl="4"/>
+            <a:endParaRPr lang="en-US" dirty="0"/>
+          </a:p>
+        </p:txBody>
+      </p:sp>
+      <p:sp>
+        <p:nvSpPr>
+          <p:cNvPr id="7" name="Title 1"/>
+          <p:cNvSpPr>
+            <a:spLocks noGrp="1"/>
+          </p:cNvSpPr>
+          <p:nvPr>
+            <p:ph type="title" hasCustomPrompt="1"/>
+          </p:nvPr>
+        </p:nvSpPr>
+        <p:spPr>
+          <a:xfrm>
+            <a:off x="4644601" y="87850"/>
+            <a:ext cx="7543800" cy="369350"/>
+          </a:xfrm>
+          <a:prstGeom prst="rect">
+            <a:avLst/>
+          </a:prstGeom>
+        </p:spPr>
+        <p:txBody>
+          <a:bodyPr>
+            <a:noAutofit/>
+          </a:bodyPr>
+          <a:lstStyle>
+            <a:lvl1pPr>
+              <a:defRPr sz="2400" spc="0">
+                <a:solidFill>
+                  <a:srgbClr val="F3F3F3"/>
+                </a:solidFill>
+                <a:effectLst>
+                  <a:outerShdw blurRad="38100" dist="38100" dir="2700000" algn="tl">
+                    <a:srgbClr val="000000">
+                      <a:alpha val="43137"/>
+                    </a:srgbClr>
+                  </a:outerShdw>
+                </a:effectLst>
+                <a:latin typeface="+mj-lt"/>
+              </a:defRPr>
+            </a:lvl1pPr>
+          </a:lstStyle>
+          <a:p>
+            <a:r>
+              <a:rPr lang="en-US" dirty="0"/>
+              <a:t>CLICK TO ADD PRIMARY TITLE</a:t>
+            </a:r>
+          </a:p>
+        </p:txBody>
+      </p:sp>
+      <p:sp>
+        <p:nvSpPr>
+          <p:cNvPr id="8" name="Stats Area"/>
+          <p:cNvSpPr>
+            <a:spLocks noGrp="1"/>
+          </p:cNvSpPr>
+          <p:nvPr>
+            <p:ph type="body" sz="quarter" idx="18" hasCustomPrompt="1"/>
+          </p:nvPr>
+        </p:nvSpPr>
+        <p:spPr>
+          <a:xfrm>
+            <a:off x="512064" y="1188720"/>
+            <a:ext cx="11164824" cy="3931920"/>
+          </a:xfrm>
+          <a:prstGeom prst="rect">
+            <a:avLst/>
+          </a:prstGeom>
+          <a:noFill/>
+          <a:ln>
+            <a:noFill/>
+          </a:ln>
+        </p:spPr>
+        <p:txBody>
+          <a:bodyPr wrap="square" lIns="0" tIns="0" rIns="0" bIns="0" anchor="ctr">
+            <a:noAutofit/>
+          </a:bodyPr>
+          <a:lstStyle>
+            <a:lvl1pPr marL="0" indent="0" algn="ctr">
+              <a:spcBef>
+                <a:spcPts val="0"/>
+              </a:spcBef>
+              <a:buNone/>
+              <a:defRPr sz="1400" b="0">
+                <a:solidFill>
+                  <a:srgbClr val="6B6B6B"/>
+                </a:solidFill>
+                <a:latin typeface="Arial"/>
+                <a:ea typeface="PingFang SC"/>
+              </a:defRPr>
+            </a:lvl1pPr>
+          </a:lstStyle>
+          <a:p>
+            <a:r>
+              <a:rPr lang="zh-CN" dirty="0"/>
+              <a:t>数据区：生成器按条目数（2–4）等分绘制数据卡</a:t>
+            </a:r>
+          </a:p>
+        </p:txBody>
+      </p:sp>
+    </p:spTree>
+    <p:extLst>
+      <p:ext uri="{BB962C8B-B14F-4D97-AF65-F5344CB8AC3E}">
+        <p14:creationId xmlns:p14="http://schemas.microsoft.com/office/powerpoint/2010/main" val="864985971"/>
+      </p:ext>
+    </p:extLst>
+  </p:cSld>
+  <p:clrMapOvr>
+    <a:masterClrMapping/>
+  </p:clrMapOvr>
+  <p:transition>
+    <p:fade thruBlk="1"/>
+  </p:transition>
+</p:sldLayout>
+</file>
+
+<file path=ppt/slideLayouts/slideLayout7.xml><?xml version="1.0" encoding="utf-8"?>
+<p:sldLayout xmlns:a="http://schemas.openxmlformats.org/drawingml/2006/main" xmlns:r="http://schemas.openxmlformats.org/officeDocument/2006/relationships" xmlns:p="http://schemas.openxmlformats.org/presentationml/2006/main" preserve="1" userDrawn="1">
+  <p:cSld name="Timeline">
+    <p:spTree>
+      <p:nvGrpSpPr>
+        <p:cNvPr id="1" name=""/>
+        <p:cNvGrpSpPr/>
+        <p:nvPr/>
+      </p:nvGrpSpPr>
+      <p:grpSpPr>
+        <a:xfrm>
+          <a:off x="0" y="0"/>
+          <a:ext cx="0" cy="0"/>
+          <a:chOff x="0" y="0"/>
+          <a:chExt cx="0" cy="0"/>
+        </a:xfrm>
+      </p:grpSpPr>
+      <p:sp>
+        <p:nvSpPr>
+          <p:cNvPr id="4" name="Text Placeholder 13"/>
+          <p:cNvSpPr>
+            <a:spLocks noGrp="1"/>
+          </p:cNvSpPr>
+          <p:nvPr>
+            <p:ph type="body" sz="quarter" idx="10" hasCustomPrompt="1"/>
+          </p:nvPr>
+        </p:nvSpPr>
+        <p:spPr>
+          <a:xfrm>
+            <a:off x="4644601" y="457200"/>
+            <a:ext cx="7543800" cy="381000"/>
+          </a:xfrm>
+          <a:prstGeom prst="rect">
+            <a:avLst/>
+          </a:prstGeom>
+        </p:spPr>
+        <p:txBody>
+          <a:bodyPr/>
+          <a:lstStyle>
+            <a:lvl1pPr marL="0" indent="0" algn="r">
+              <a:lnSpc>
+                <a:spcPct val="150000"/>
+              </a:lnSpc>
+              <a:buNone/>
+              <a:defRPr sz="1500" b="0">
+                <a:solidFill>
+                  <a:schemeClr val="bg1"/>
+                </a:solidFill>
+                <a:latin typeface="+mj-lt"/>
+              </a:defRPr>
+            </a:lvl1pPr>
+            <a:lvl5pPr algn="r">
+              <a:lnSpc>
+                <a:spcPct val="150000"/>
+              </a:lnSpc>
+              <a:defRPr sz="1500" b="0">
+                <a:solidFill>
+                  <a:schemeClr val="bg1"/>
+                </a:solidFill>
+                <a:latin typeface="+mj-lt"/>
+              </a:defRPr>
+            </a:lvl5pPr>
+          </a:lstStyle>
+          <a:p>
+            <a:pPr lvl="0"/>
+            <a:r>
+              <a:rPr lang="en-US" dirty="0"/>
+              <a:t>Click to add Secondary Title</a:t>
+            </a:r>
+          </a:p>
+          <a:p>
+            <a:pPr lvl="4"/>
+            <a:endParaRPr lang="en-US" dirty="0"/>
+          </a:p>
+        </p:txBody>
+      </p:sp>
+      <p:sp>
+        <p:nvSpPr>
+          <p:cNvPr id="7" name="Title 1"/>
+          <p:cNvSpPr>
+            <a:spLocks noGrp="1"/>
+          </p:cNvSpPr>
+          <p:nvPr>
+            <p:ph type="title" hasCustomPrompt="1"/>
+          </p:nvPr>
+        </p:nvSpPr>
+        <p:spPr>
+          <a:xfrm>
+            <a:off x="4644601" y="87850"/>
+            <a:ext cx="7543800" cy="369350"/>
+          </a:xfrm>
+          <a:prstGeom prst="rect">
+            <a:avLst/>
+          </a:prstGeom>
+        </p:spPr>
+        <p:txBody>
+          <a:bodyPr>
+            <a:noAutofit/>
+          </a:bodyPr>
+          <a:lstStyle>
+            <a:lvl1pPr>
+              <a:defRPr sz="2400" spc="0">
+                <a:solidFill>
+                  <a:srgbClr val="F3F3F3"/>
+                </a:solidFill>
+                <a:effectLst>
+                  <a:outerShdw blurRad="38100" dist="38100" dir="2700000" algn="tl">
+                    <a:srgbClr val="000000">
+                      <a:alpha val="43137"/>
+                    </a:srgbClr>
+                  </a:outerShdw>
+                </a:effectLst>
+                <a:latin typeface="+mj-lt"/>
+              </a:defRPr>
+            </a:lvl1pPr>
+          </a:lstStyle>
+          <a:p>
+            <a:r>
+              <a:rPr lang="en-US" dirty="0"/>
+              <a:t>CLICK TO ADD PRIMARY TITLE</a:t>
+            </a:r>
+          </a:p>
+        </p:txBody>
+      </p:sp>
+      <p:sp>
+        <p:nvSpPr>
+          <p:cNvPr id="8" name="Timeline Area"/>
+          <p:cNvSpPr>
+            <a:spLocks noGrp="1"/>
+          </p:cNvSpPr>
+          <p:nvPr>
+            <p:ph type="body" sz="quarter" idx="19" hasCustomPrompt="1"/>
+          </p:nvPr>
+        </p:nvSpPr>
+        <p:spPr>
+          <a:xfrm>
+            <a:off x="512064" y="1188720"/>
+            <a:ext cx="11164824" cy="3931920"/>
+          </a:xfrm>
+          <a:prstGeom prst="rect">
+            <a:avLst/>
+          </a:prstGeom>
+          <a:noFill/>
+          <a:ln>
+            <a:noFill/>
+          </a:ln>
+        </p:spPr>
+        <p:txBody>
+          <a:bodyPr wrap="square" lIns="0" tIns="0" rIns="0" bIns="0" anchor="ctr">
+            <a:noAutofit/>
+          </a:bodyPr>
+          <a:lstStyle>
+            <a:lvl1pPr marL="0" indent="0" algn="ctr">
+              <a:spcBef>
+                <a:spcPts val="0"/>
+              </a:spcBef>
+              <a:buNone/>
+              <a:defRPr sz="1400" b="0">
+                <a:solidFill>
+                  <a:srgbClr val="6B6B6B"/>
+                </a:solidFill>
+                <a:latin typeface="Arial"/>
+                <a:ea typeface="PingFang SC"/>
+              </a:defRPr>
+            </a:lvl1pPr>
+          </a:lstStyle>
+          <a:p>
+            <a:r>
+              <a:rPr lang="zh-CN" dirty="0"/>
+              <a:t>时间线区：生成器按节点数（3–6）等距绘制</a:t>
+            </a:r>
+          </a:p>
+        </p:txBody>
+      </p:sp>
+    </p:spTree>
+    <p:extLst>
+      <p:ext uri="{BB962C8B-B14F-4D97-AF65-F5344CB8AC3E}">
+        <p14:creationId xmlns:p14="http://schemas.microsoft.com/office/powerpoint/2010/main" val="864985971"/>
+      </p:ext>
+    </p:extLst>
+  </p:cSld>
+  <p:clrMapOvr>
+    <a:masterClrMapping/>
+  </p:clrMapOvr>
+  <p:transition>
+    <p:fade thruBlk="1"/>
+  </p:transition>
+</p:sldLayout>
+</file>
+
+<file path=ppt/slideLayouts/slideLayout8.xml><?xml version="1.0" encoding="utf-8"?>
+<p:sldLayout xmlns:a="http://schemas.openxmlformats.org/drawingml/2006/main" xmlns:r="http://schemas.openxmlformats.org/officeDocument/2006/relationships" xmlns:p="http://schemas.openxmlformats.org/presentationml/2006/main" preserve="1" userDrawn="1">
+  <p:cSld name="Image + Text">
+    <p:spTree>
+      <p:nvGrpSpPr>
+        <p:cNvPr id="1" name=""/>
+        <p:cNvGrpSpPr/>
+        <p:nvPr/>
+      </p:nvGrpSpPr>
+      <p:grpSpPr>
+        <a:xfrm>
+          <a:off x="0" y="0"/>
+          <a:ext cx="0" cy="0"/>
+          <a:chOff x="0" y="0"/>
+          <a:chExt cx="0" cy="0"/>
+        </a:xfrm>
+      </p:grpSpPr>
+      <p:sp>
+        <p:nvSpPr>
+          <p:cNvPr id="4" name="Text Placeholder 13"/>
+          <p:cNvSpPr>
+            <a:spLocks noGrp="1"/>
+          </p:cNvSpPr>
+          <p:nvPr>
+            <p:ph type="body" sz="quarter" idx="10" hasCustomPrompt="1"/>
+          </p:nvPr>
+        </p:nvSpPr>
+        <p:spPr>
+          <a:xfrm>
+            <a:off x="4644601" y="457200"/>
+            <a:ext cx="7543800" cy="381000"/>
+          </a:xfrm>
+          <a:prstGeom prst="rect">
+            <a:avLst/>
+          </a:prstGeom>
+        </p:spPr>
+        <p:txBody>
+          <a:bodyPr/>
+          <a:lstStyle>
+            <a:lvl1pPr marL="0" indent="0" algn="r">
+              <a:lnSpc>
+                <a:spcPct val="150000"/>
+              </a:lnSpc>
+              <a:buNone/>
+              <a:defRPr sz="1500" b="0">
+                <a:solidFill>
+                  <a:schemeClr val="bg1"/>
+                </a:solidFill>
+                <a:latin typeface="+mj-lt"/>
+              </a:defRPr>
+            </a:lvl1pPr>
+            <a:lvl5pPr algn="r">
+              <a:lnSpc>
+                <a:spcPct val="150000"/>
+              </a:lnSpc>
+              <a:defRPr sz="1500" b="0">
+                <a:solidFill>
+                  <a:schemeClr val="bg1"/>
+                </a:solidFill>
+                <a:latin typeface="+mj-lt"/>
+              </a:defRPr>
+            </a:lvl5pPr>
+          </a:lstStyle>
+          <a:p>
+            <a:pPr lvl="0"/>
+            <a:r>
+              <a:rPr lang="en-US" dirty="0"/>
+              <a:t>Click to add Secondary Title</a:t>
+            </a:r>
+          </a:p>
+          <a:p>
+            <a:pPr lvl="4"/>
+            <a:endParaRPr lang="en-US" dirty="0"/>
+          </a:p>
+        </p:txBody>
+      </p:sp>
+      <p:sp>
+        <p:nvSpPr>
+          <p:cNvPr id="7" name="Title 1"/>
+          <p:cNvSpPr>
+            <a:spLocks noGrp="1"/>
+          </p:cNvSpPr>
+          <p:nvPr>
+            <p:ph type="title" hasCustomPrompt="1"/>
+          </p:nvPr>
+        </p:nvSpPr>
+        <p:spPr>
+          <a:xfrm>
+            <a:off x="4644601" y="87850"/>
+            <a:ext cx="7543800" cy="369350"/>
+          </a:xfrm>
+          <a:prstGeom prst="rect">
+            <a:avLst/>
+          </a:prstGeom>
+        </p:spPr>
+        <p:txBody>
+          <a:bodyPr>
+            <a:noAutofit/>
+          </a:bodyPr>
+          <a:lstStyle>
+            <a:lvl1pPr>
+              <a:defRPr sz="2400" spc="0">
+                <a:solidFill>
+                  <a:srgbClr val="F3F3F3"/>
+                </a:solidFill>
+                <a:effectLst>
+                  <a:outerShdw blurRad="38100" dist="38100" dir="2700000" algn="tl">
+                    <a:srgbClr val="000000">
+                      <a:alpha val="43137"/>
+                    </a:srgbClr>
+                  </a:outerShdw>
+                </a:effectLst>
+                <a:latin typeface="+mj-lt"/>
+              </a:defRPr>
+            </a:lvl1pPr>
+          </a:lstStyle>
+          <a:p>
+            <a:r>
+              <a:rPr lang="en-US" dirty="0"/>
+              <a:t>CLICK TO ADD PRIMARY TITLE</a:t>
+            </a:r>
+          </a:p>
+        </p:txBody>
+      </p:sp>
+      <p:sp>
+        <p:nvSpPr>
+          <p:cNvPr id="8" name="Image Frame"/>
+          <p:cNvSpPr>
+            <a:spLocks noGrp="1"/>
+          </p:cNvSpPr>
+          <p:nvPr>
+            <p:ph type="body" sz="quarter" idx="20" hasCustomPrompt="1"/>
+          </p:nvPr>
+        </p:nvSpPr>
+        <p:spPr>
+          <a:xfrm>
+            <a:off x="512064" y="1188720"/>
+            <a:ext cx="6986016" cy="3931920"/>
+          </a:xfrm>
+          <a:prstGeom prst="rect">
+            <a:avLst/>
+          </a:prstGeom>
+          <a:noFill/>
+          <a:ln>
+            <a:noFill/>
+          </a:ln>
+        </p:spPr>
+        <p:txBody>
+          <a:bodyPr wrap="square" lIns="0" tIns="0" rIns="0" bIns="0" anchor="ctr">
+            <a:noAutofit/>
+          </a:bodyPr>
+          <a:lstStyle>
+            <a:lvl1pPr marL="0" indent="0" algn="ctr">
+              <a:spcBef>
+                <a:spcPts val="0"/>
+              </a:spcBef>
+              <a:buNone/>
+              <a:defRPr sz="1400" b="0">
+                <a:solidFill>
+                  <a:srgbClr val="6B6B6B"/>
+                </a:solidFill>
+                <a:latin typeface="Arial"/>
+                <a:ea typeface="PingFang SC"/>
+              </a:defRPr>
+            </a:lvl1pPr>
+          </a:lstStyle>
+          <a:p>
+            <a:r>
+              <a:rPr lang="zh-CN" dirty="0"/>
+              <a:t>图框（16:9）：图片等比缩放、居中，不裁切</a:t>
+            </a:r>
+          </a:p>
+        </p:txBody>
+      </p:sp>
+      <p:sp>
+        <p:nvSpPr>
+          <p:cNvPr id="9" name="Text Area"/>
+          <p:cNvSpPr>
+            <a:spLocks noGrp="1"/>
+          </p:cNvSpPr>
+          <p:nvPr>
+            <p:ph type="body" sz="quarter" idx="21" hasCustomPrompt="1"/>
+          </p:nvPr>
+        </p:nvSpPr>
+        <p:spPr>
+          <a:xfrm>
+            <a:off x="7772400" y="1188720"/>
+            <a:ext cx="3904488" cy="3931920"/>
+          </a:xfrm>
+          <a:prstGeom prst="rect">
+            <a:avLst/>
+          </a:prstGeom>
+          <a:noFill/>
+          <a:ln>
+            <a:noFill/>
+          </a:ln>
+        </p:spPr>
+        <p:txBody>
+          <a:bodyPr wrap="square" lIns="0" tIns="0" rIns="0" bIns="0" anchor="ctr">
+            <a:noAutofit/>
+          </a:bodyPr>
+          <a:lstStyle>
+            <a:lvl1pPr marL="228600" indent="-228600" algn="l">
+              <a:lnSpc>
+                <a:spcPct val="120000"/>
+              </a:lnSpc>
+              <a:spcBef>
+                <a:spcPts val="0"/>
+              </a:spcBef>
+              <a:spcAft>
+                <a:spcPts val="900"/>
+              </a:spcAft>
+              <a:buClr>
+                <a:srgbClr val="6B6B6B"/>
+              </a:buClr>
+              <a:buSzPct val="100000"/>
+              <a:buFont typeface="Arial"/>
+              <a:buChar char="•"/>
+              <a:defRPr sz="1600" b="0">
+                <a:solidFill>
+                  <a:srgbClr val="1A1A1A"/>
+                </a:solidFill>
+                <a:latin typeface="Arial"/>
+                <a:ea typeface="PingFang SC"/>
+              </a:defRPr>
+            </a:lvl1pPr>
+          </a:lstStyle>
+          <a:p>
+            <a:r>
+              <a:rPr lang="zh-CN" dirty="0"/>
+              <a:t>要点（建议不超过 5 条）</a:t>
+            </a:r>
+          </a:p>
+        </p:txBody>
+      </p:sp>
+    </p:spTree>
+    <p:extLst>
+      <p:ext uri="{BB962C8B-B14F-4D97-AF65-F5344CB8AC3E}">
+        <p14:creationId xmlns:p14="http://schemas.microsoft.com/office/powerpoint/2010/main" val="864985971"/>
+      </p:ext>
+    </p:extLst>
+  </p:cSld>
+  <p:clrMapOvr>
+    <a:masterClrMapping/>
+  </p:clrMapOvr>
+  <p:transition>
+    <p:fade thruBlk="1"/>
+  </p:transition>
+</p:sldLayout>
+</file>
+
 <file path=ppt/slideMasters/slideMaster1.xml><?xml version="1.0" encoding="utf-8"?>
 <p:sldMaster xmlns:a="http://schemas.openxmlformats.org/drawingml/2006/main" xmlns:r="http://schemas.openxmlformats.org/officeDocument/2006/relationships" xmlns:p="http://schemas.openxmlformats.org/presentationml/2006/main">
   <p:cSld>
@@ -2132,6 +2953,10 @@
     <p:sldLayoutId id="2147483687" r:id="rId2"/>
     <p:sldLayoutId id="2147483688" r:id="rId3"/>
     <p:sldLayoutId id="2147483689" r:id="rId6"/>
+    <p:sldLayoutId id="2147483690" r:id="rId7"/>
+    <p:sldLayoutId id="2147483691" r:id="rId8"/>
+    <p:sldLayoutId id="2147483692" r:id="rId9"/>
+    <p:sldLayoutId id="2147483693" r:id="rId10"/>
   </p:sldLayoutIdLst>
   <p:transition>
     <p:fade thruBlk="1"/>

</xml_diff>